<commit_message>
feat: met à jour le support de soutenance JALB-Decrochage
</commit_message>
<xml_diff>
--- a/docs/JALB-Decrochage-l1.pptx
+++ b/docs/JALB-Decrochage-l1.pptx
@@ -5,7 +5,7 @@
     <p:sldMasterId id="2147483648" r:id="rId1"/>
   </p:sldMasterIdLst>
   <p:notesMasterIdLst>
-    <p:notesMasterId r:id="rId52"/>
+    <p:notesMasterId r:id="rId54"/>
   </p:notesMasterIdLst>
   <p:sldIdLst>
     <p:sldId id="256" r:id="rId2"/>
@@ -58,6 +58,8 @@
     <p:sldId id="718" r:id="rId49"/>
     <p:sldId id="723" r:id="rId50"/>
     <p:sldId id="729" r:id="rId51"/>
+    <p:sldId id="754" r:id="rId52"/>
+    <p:sldId id="755" r:id="rId53"/>
   </p:sldIdLst>
   <p:sldSz cx="18288000" cy="10287000"/>
   <p:notesSz cx="6858000" cy="9144000"/>
@@ -3852,7 +3854,173 @@
     </p:spTree>
     <p:extLst>
       <p:ext uri="{BB962C8B-B14F-4D97-AF65-F5344CB8AC3E}">
+        <p14:creationId xmlns:p14="http://schemas.microsoft.com/office/powerpoint/2010/main" val="3587350278"/>
+      </p:ext>
+    </p:extLst>
+  </p:cSld>
+  <p:clrMapOvr>
+    <a:masterClrMapping/>
+  </p:clrMapOvr>
+</p:notes>
+</file>
+
+<file path=ppt/notesSlides/notesSlide38.xml><?xml version="1.0" encoding="utf-8"?>
+<p:notes xmlns:a="http://schemas.openxmlformats.org/drawingml/2006/main" xmlns:r="http://schemas.openxmlformats.org/officeDocument/2006/relationships" xmlns:p="http://schemas.openxmlformats.org/presentationml/2006/main">
+  <p:cSld>
+    <p:spTree>
+      <p:nvGrpSpPr>
+        <p:cNvPr id="1" name=""/>
+        <p:cNvGrpSpPr/>
+        <p:nvPr/>
+      </p:nvGrpSpPr>
+      <p:grpSpPr>
+        <a:xfrm>
+          <a:off x="0" y="0"/>
+          <a:ext cx="0" cy="0"/>
+          <a:chOff x="0" y="0"/>
+          <a:chExt cx="0" cy="0"/>
+        </a:xfrm>
+      </p:grpSpPr>
+      <p:sp>
+        <p:nvSpPr>
+          <p:cNvPr id="2" name="Espace réservé de l'image des diapositives 1"/>
+          <p:cNvSpPr>
+            <a:spLocks noGrp="1" noRot="1" noChangeAspect="1"/>
+          </p:cNvSpPr>
+          <p:nvPr>
+            <p:ph type="sldImg"/>
+          </p:nvPr>
+        </p:nvSpPr>
+        <p:spPr>
+          <a:xfrm>
+            <a:off x="685800" y="1143000"/>
+            <a:ext cx="5486400" cy="3086100"/>
+          </a:xfrm>
+          <a:prstGeom prst="rect">
+            <a:avLst/>
+          </a:prstGeom>
+          <a:noFill/>
+          <a:ln w="12700">
+            <a:solidFill>
+              <a:prstClr val="black"/>
+            </a:solidFill>
+          </a:ln>
+        </p:spPr>
+      </p:sp>
+      <p:sp>
+        <p:nvSpPr>
+          <p:cNvPr id="3" name="Espace réservé des notes 2"/>
+          <p:cNvSpPr>
+            <a:spLocks noGrp="1"/>
+          </p:cNvSpPr>
+          <p:nvPr>
+            <p:ph type="body" idx="1"/>
+          </p:nvPr>
+        </p:nvSpPr>
+        <p:spPr>
+          <a:xfrm>
+            <a:off x="685800" y="4400550"/>
+            <a:ext cx="5486400" cy="3600450"/>
+          </a:xfrm>
+          <a:prstGeom prst="rect">
+            <a:avLst/>
+          </a:prstGeom>
+        </p:spPr>
+        <p:txBody>
+          <a:bodyPr/>
+          <a:lstStyle/>
+          <a:p>
+            <a:endParaRPr lang="fr-FR" dirty="0"/>
+          </a:p>
+        </p:txBody>
+      </p:sp>
+    </p:spTree>
+    <p:extLst>
+      <p:ext uri="{BB962C8B-B14F-4D97-AF65-F5344CB8AC3E}">
         <p14:creationId xmlns:p14="http://schemas.microsoft.com/office/powerpoint/2010/main" val="3509161283"/>
+      </p:ext>
+    </p:extLst>
+  </p:cSld>
+  <p:clrMapOvr>
+    <a:masterClrMapping/>
+  </p:clrMapOvr>
+</p:notes>
+</file>
+
+<file path=ppt/notesSlides/notesSlide39.xml><?xml version="1.0" encoding="utf-8"?>
+<p:notes xmlns:a="http://schemas.openxmlformats.org/drawingml/2006/main" xmlns:r="http://schemas.openxmlformats.org/officeDocument/2006/relationships" xmlns:p="http://schemas.openxmlformats.org/presentationml/2006/main">
+  <p:cSld>
+    <p:spTree>
+      <p:nvGrpSpPr>
+        <p:cNvPr id="1" name=""/>
+        <p:cNvGrpSpPr/>
+        <p:nvPr/>
+      </p:nvGrpSpPr>
+      <p:grpSpPr>
+        <a:xfrm>
+          <a:off x="0" y="0"/>
+          <a:ext cx="0" cy="0"/>
+          <a:chOff x="0" y="0"/>
+          <a:chExt cx="0" cy="0"/>
+        </a:xfrm>
+      </p:grpSpPr>
+      <p:sp>
+        <p:nvSpPr>
+          <p:cNvPr id="2" name="Espace réservé de l'image des diapositives 1"/>
+          <p:cNvSpPr>
+            <a:spLocks noGrp="1" noRot="1" noChangeAspect="1"/>
+          </p:cNvSpPr>
+          <p:nvPr>
+            <p:ph type="sldImg"/>
+          </p:nvPr>
+        </p:nvSpPr>
+        <p:spPr>
+          <a:xfrm>
+            <a:off x="685800" y="1143000"/>
+            <a:ext cx="5486400" cy="3086100"/>
+          </a:xfrm>
+          <a:prstGeom prst="rect">
+            <a:avLst/>
+          </a:prstGeom>
+          <a:noFill/>
+          <a:ln w="12700">
+            <a:solidFill>
+              <a:prstClr val="black"/>
+            </a:solidFill>
+          </a:ln>
+        </p:spPr>
+      </p:sp>
+      <p:sp>
+        <p:nvSpPr>
+          <p:cNvPr id="3" name="Espace réservé des notes 2"/>
+          <p:cNvSpPr>
+            <a:spLocks noGrp="1"/>
+          </p:cNvSpPr>
+          <p:nvPr>
+            <p:ph type="body" idx="1"/>
+          </p:nvPr>
+        </p:nvSpPr>
+        <p:spPr>
+          <a:xfrm>
+            <a:off x="685800" y="4400550"/>
+            <a:ext cx="5486400" cy="3600450"/>
+          </a:xfrm>
+          <a:prstGeom prst="rect">
+            <a:avLst/>
+          </a:prstGeom>
+        </p:spPr>
+        <p:txBody>
+          <a:bodyPr/>
+          <a:lstStyle/>
+          <a:p>
+            <a:endParaRPr lang="fr-FR" dirty="0"/>
+          </a:p>
+        </p:txBody>
+      </p:sp>
+    </p:spTree>
+    <p:extLst>
+      <p:ext uri="{BB962C8B-B14F-4D97-AF65-F5344CB8AC3E}">
+        <p14:creationId xmlns:p14="http://schemas.microsoft.com/office/powerpoint/2010/main" val="3587350278"/>
       </p:ext>
     </p:extLst>
   </p:cSld>
@@ -3927,6 +4095,107 @@
         <p:spPr/>
       </p:sp>
     </p:spTree>
+  </p:cSld>
+  <p:clrMapOvr>
+    <a:masterClrMapping/>
+  </p:clrMapOvr>
+</p:notes>
+</file>
+
+<file path=ppt/notesSlides/notesSlide40.xml><?xml version="1.0" encoding="utf-8"?>
+<p:notes xmlns:a="http://schemas.openxmlformats.org/drawingml/2006/main" xmlns:r="http://schemas.openxmlformats.org/officeDocument/2006/relationships" xmlns:p="http://schemas.openxmlformats.org/presentationml/2006/main">
+  <p:cSld>
+    <p:spTree>
+      <p:nvGrpSpPr>
+        <p:cNvPr id="1" name="">
+          <a:extLst>
+            <a:ext uri="{FF2B5EF4-FFF2-40B4-BE49-F238E27FC236}">
+              <a16:creationId xmlns:a16="http://schemas.microsoft.com/office/drawing/2014/main" id="{97387F41-0B83-4910-7B83-B0B46611564F}"/>
+            </a:ext>
+          </a:extLst>
+        </p:cNvPr>
+        <p:cNvGrpSpPr/>
+        <p:nvPr/>
+      </p:nvGrpSpPr>
+      <p:grpSpPr>
+        <a:xfrm>
+          <a:off x="0" y="0"/>
+          <a:ext cx="0" cy="0"/>
+          <a:chOff x="0" y="0"/>
+          <a:chExt cx="0" cy="0"/>
+        </a:xfrm>
+      </p:grpSpPr>
+      <p:sp>
+        <p:nvSpPr>
+          <p:cNvPr id="2" name="Espace réservé de l'image des diapositives 1">
+            <a:extLst>
+              <a:ext uri="{FF2B5EF4-FFF2-40B4-BE49-F238E27FC236}">
+                <a16:creationId xmlns:a16="http://schemas.microsoft.com/office/drawing/2014/main" id="{9C0BAA41-26DC-301F-D229-52E4AAAA28C0}"/>
+              </a:ext>
+            </a:extLst>
+          </p:cNvPr>
+          <p:cNvSpPr>
+            <a:spLocks noGrp="1" noRot="1" noChangeAspect="1"/>
+          </p:cNvSpPr>
+          <p:nvPr>
+            <p:ph type="sldImg"/>
+          </p:nvPr>
+        </p:nvSpPr>
+        <p:spPr>
+          <a:xfrm>
+            <a:off x="685800" y="1143000"/>
+            <a:ext cx="5486400" cy="3086100"/>
+          </a:xfrm>
+          <a:prstGeom prst="rect">
+            <a:avLst/>
+          </a:prstGeom>
+          <a:noFill/>
+          <a:ln w="12700">
+            <a:solidFill>
+              <a:prstClr val="black"/>
+            </a:solidFill>
+          </a:ln>
+        </p:spPr>
+      </p:sp>
+      <p:sp>
+        <p:nvSpPr>
+          <p:cNvPr id="3" name="Espace réservé des notes 2">
+            <a:extLst>
+              <a:ext uri="{FF2B5EF4-FFF2-40B4-BE49-F238E27FC236}">
+                <a16:creationId xmlns:a16="http://schemas.microsoft.com/office/drawing/2014/main" id="{0E8FA0E9-E19A-D695-19DA-2C51B6F8E8DB}"/>
+              </a:ext>
+            </a:extLst>
+          </p:cNvPr>
+          <p:cNvSpPr>
+            <a:spLocks noGrp="1"/>
+          </p:cNvSpPr>
+          <p:nvPr>
+            <p:ph type="body" idx="1"/>
+          </p:nvPr>
+        </p:nvSpPr>
+        <p:spPr>
+          <a:xfrm>
+            <a:off x="685800" y="4400550"/>
+            <a:ext cx="5486400" cy="3600450"/>
+          </a:xfrm>
+          <a:prstGeom prst="rect">
+            <a:avLst/>
+          </a:prstGeom>
+        </p:spPr>
+        <p:txBody>
+          <a:bodyPr/>
+          <a:lstStyle/>
+          <a:p>
+            <a:endParaRPr lang="fr-FR" dirty="0"/>
+          </a:p>
+        </p:txBody>
+      </p:sp>
+    </p:spTree>
+    <p:extLst>
+      <p:ext uri="{BB962C8B-B14F-4D97-AF65-F5344CB8AC3E}">
+        <p14:creationId xmlns:p14="http://schemas.microsoft.com/office/powerpoint/2010/main" val="2402123756"/>
+      </p:ext>
+    </p:extLst>
   </p:cSld>
   <p:clrMapOvr>
     <a:masterClrMapping/>
@@ -62071,6 +62340,636 @@
 </p:sld>
 </file>
 
+<file path=ppt/slides/slide51.xml><?xml version="1.0" encoding="utf-8"?>
+<p:sld xmlns:a="http://schemas.openxmlformats.org/drawingml/2006/main" xmlns:r="http://schemas.openxmlformats.org/officeDocument/2006/relationships" xmlns:p="http://schemas.openxmlformats.org/presentationml/2006/main">
+  <p:cSld>
+    <p:spTree>
+      <p:nvGrpSpPr>
+        <p:cNvPr id="1" name=""/>
+        <p:cNvGrpSpPr/>
+        <p:nvPr/>
+      </p:nvGrpSpPr>
+      <p:grpSpPr>
+        <a:xfrm>
+          <a:off x="0" y="0"/>
+          <a:ext cx="0" cy="0"/>
+          <a:chOff x="0" y="0"/>
+          <a:chExt cx="0" cy="0"/>
+        </a:xfrm>
+      </p:grpSpPr>
+      <p:sp>
+        <p:nvSpPr>
+          <p:cNvPr id="101" name="R101"/>
+          <p:cNvSpPr/>
+          <p:nvPr/>
+        </p:nvSpPr>
+        <p:spPr>
+          <a:xfrm>
+            <a:off x="1047750" y="800100"/>
+            <a:ext cx="16192500" cy="657225"/>
+          </a:xfrm>
+          <a:prstGeom prst="roundRect">
+            <a:avLst>
+              <a:gd name="adj" fmla="val 8700"/>
+            </a:avLst>
+          </a:prstGeom>
+          <a:solidFill>
+            <a:srgbClr val="E4F3F7"/>
+          </a:solidFill>
+          <a:ln>
+            <a:noFill/>
+          </a:ln>
+        </p:spPr>
+        <p:txBody>
+          <a:bodyPr rtlCol="0" anchor="ctr"/>
+          <a:lstStyle/>
+          <a:p>
+            <a:endParaRPr lang="fr-FR" dirty="0"/>
+          </a:p>
+        </p:txBody>
+      </p:sp>
+      <p:sp>
+        <p:nvSpPr>
+          <p:cNvPr id="102" name="T102"/>
+          <p:cNvSpPr txBox="1"/>
+          <p:nvPr/>
+        </p:nvSpPr>
+        <p:spPr>
+          <a:xfrm>
+            <a:off x="1771650" y="995363"/>
+            <a:ext cx="9500000" cy="304800"/>
+          </a:xfrm>
+          <a:prstGeom prst="rect">
+            <a:avLst/>
+          </a:prstGeom>
+          <a:noFill/>
+        </p:spPr>
+        <p:txBody>
+          <a:bodyPr wrap="square" lIns="27432" tIns="27432" rIns="27432" bIns="27432" anchor="t">
+            <a:noAutofit/>
+          </a:bodyPr>
+          <a:lstStyle/>
+          <a:p>
+            <a:pPr algn="l"/>
+            <a:r>
+              <a:rPr lang="fr-FR" sz="1800" b="1" spc="162" noProof="0" dirty="0">
+                <a:solidFill>
+                  <a:srgbClr val="1A6A77"/>
+                </a:solidFill>
+                <a:latin typeface="Arial"/>
+              </a:rPr>
+              <a:t>Annexe A7 : Qualité logicielle — tests unitaires</a:t>
+            </a:r>
+          </a:p>
+        </p:txBody>
+      </p:sp>
+      <p:sp>
+        <p:nvSpPr>
+          <p:cNvPr id="103" name="T103"/>
+          <p:cNvSpPr txBox="1"/>
+          <p:nvPr/>
+        </p:nvSpPr>
+        <p:spPr>
+          <a:xfrm>
+            <a:off x="11500000" y="971550"/>
+            <a:ext cx="5500000" cy="352425"/>
+          </a:xfrm>
+          <a:prstGeom prst="rect">
+            <a:avLst/>
+          </a:prstGeom>
+          <a:noFill/>
+        </p:spPr>
+        <p:txBody>
+          <a:bodyPr wrap="square" lIns="27432" tIns="27432" rIns="27432" bIns="27432" anchor="t">
+            <a:noAutofit/>
+          </a:bodyPr>
+          <a:lstStyle/>
+          <a:p>
+            <a:pPr algn="r"/>
+            <a:r>
+              <a:rPr lang="fr-FR" sz="1800" b="0" noProof="0" dirty="0">
+                <a:solidFill>
+                  <a:srgbClr val="1A6A77"/>
+                </a:solidFill>
+                <a:latin typeface="Arial"/>
+              </a:rPr>
+              <a:t>249 tests</a:t>
+            </a:r>
+          </a:p>
+        </p:txBody>
+      </p:sp>
+      <p:sp>
+        <p:nvSpPr>
+          <p:cNvPr id="174" name="T174"/>
+          <p:cNvSpPr txBox="1"/>
+          <p:nvPr/>
+        </p:nvSpPr>
+        <p:spPr>
+          <a:xfrm>
+            <a:off x="1054100" y="9461500"/>
+            <a:ext cx="13970000" cy="355600"/>
+          </a:xfrm>
+          <a:prstGeom prst="rect">
+            <a:avLst/>
+          </a:prstGeom>
+          <a:noFill/>
+        </p:spPr>
+        <p:txBody>
+          <a:bodyPr wrap="square" lIns="27432" tIns="27432" rIns="27432" bIns="27432" anchor="t">
+            <a:noAutofit/>
+          </a:bodyPr>
+          <a:lstStyle/>
+          <a:p>
+            <a:pPr algn="l"/>
+            <a:r>
+              <a:rPr lang="fr-FR" b="0" noProof="0" dirty="0">
+                <a:solidFill>
+                  <a:srgbClr val="6F6F6F"/>
+                </a:solidFill>
+                <a:latin typeface="Arial"/>
+              </a:rPr>
+              <a:t>Annexe A7 · sources : sortie </a:t>
+            </a:r>
+            <a:r>
+              <a:rPr lang="fr-FR" b="0" noProof="0" dirty="0" err="1">
+                <a:solidFill>
+                  <a:srgbClr val="6F6F6F"/>
+                </a:solidFill>
+                <a:latin typeface="Arial"/>
+              </a:rPr>
+              <a:t>pytest</a:t>
+            </a:r>
+            <a:r>
+              <a:rPr lang="fr-FR" b="0" noProof="0" dirty="0">
+                <a:solidFill>
+                  <a:srgbClr val="6F6F6F"/>
+                </a:solidFill>
+                <a:latin typeface="Arial"/>
+              </a:rPr>
+              <a:t> locale</a:t>
+            </a:r>
+          </a:p>
+        </p:txBody>
+      </p:sp>
+      <p:sp>
+        <p:nvSpPr>
+          <p:cNvPr id="175" name="T175"/>
+          <p:cNvSpPr txBox="1"/>
+          <p:nvPr/>
+        </p:nvSpPr>
+        <p:spPr>
+          <a:xfrm>
+            <a:off x="17048886" y="9309100"/>
+            <a:ext cx="273913" cy="304800"/>
+          </a:xfrm>
+          <a:prstGeom prst="rect">
+            <a:avLst/>
+          </a:prstGeom>
+          <a:noFill/>
+        </p:spPr>
+        <p:txBody>
+          <a:bodyPr wrap="none" lIns="27432" tIns="27432" rIns="27432" bIns="27432" anchor="ctr" anchorCtr="0">
+            <a:noAutofit/>
+          </a:bodyPr>
+          <a:lstStyle/>
+          <a:p>
+            <a:pPr algn="l"/>
+            <a:r>
+              <a:rPr lang="fr-FR" sz="1400" b="1" noProof="0" dirty="0">
+                <a:solidFill>
+                  <a:srgbClr val="56B9CA"/>
+                </a:solidFill>
+                <a:latin typeface="Arial"/>
+                <a:cs typeface="Arial"/>
+              </a:rPr>
+              <a:t>51</a:t>
+            </a:r>
+          </a:p>
+        </p:txBody>
+      </p:sp>
+      <p:pic>
+        <p:nvPicPr>
+          <p:cNvPr id="2" name="Image 1">
+            <a:extLst>
+              <a:ext uri="{FF2B5EF4-FFF2-40B4-BE49-F238E27FC236}">
+                <a16:creationId xmlns:a16="http://schemas.microsoft.com/office/drawing/2014/main" id="{4C698E25-5590-3A5B-120A-3BB92715080B}"/>
+              </a:ext>
+            </a:extLst>
+          </p:cNvPr>
+          <p:cNvPicPr>
+            <a:picLocks noChangeAspect="1"/>
+          </p:cNvPicPr>
+          <p:nvPr/>
+        </p:nvPicPr>
+        <p:blipFill>
+          <a:blip r:embed="rId3"/>
+          <a:stretch>
+            <a:fillRect/>
+          </a:stretch>
+        </p:blipFill>
+        <p:spPr>
+          <a:xfrm>
+            <a:off x="1676400" y="1778000"/>
+            <a:ext cx="14922500" cy="7454900"/>
+          </a:xfrm>
+          <a:prstGeom prst="rect">
+            <a:avLst/>
+          </a:prstGeom>
+        </p:spPr>
+      </p:pic>
+    </p:spTree>
+    <p:extLst>
+      <p:ext uri="{BB962C8B-B14F-4D97-AF65-F5344CB8AC3E}">
+        <p14:creationId xmlns:p14="http://schemas.microsoft.com/office/powerpoint/2010/main" val="1550836700"/>
+      </p:ext>
+    </p:extLst>
+  </p:cSld>
+  <p:clrMapOvr>
+    <a:masterClrMapping/>
+  </p:clrMapOvr>
+</p:sld>
+</file>
+
+<file path=ppt/slides/slide52.xml><?xml version="1.0" encoding="utf-8"?>
+<p:sld xmlns:a="http://schemas.openxmlformats.org/drawingml/2006/main" xmlns:r="http://schemas.openxmlformats.org/officeDocument/2006/relationships" xmlns:p="http://schemas.openxmlformats.org/presentationml/2006/main">
+  <p:cSld>
+    <p:spTree>
+      <p:nvGrpSpPr>
+        <p:cNvPr id="1" name="">
+          <a:extLst>
+            <a:ext uri="{FF2B5EF4-FFF2-40B4-BE49-F238E27FC236}">
+              <a16:creationId xmlns:a16="http://schemas.microsoft.com/office/drawing/2014/main" id="{C97FBDD9-F3FC-BBDA-0AE7-95E236C0147E}"/>
+            </a:ext>
+          </a:extLst>
+        </p:cNvPr>
+        <p:cNvGrpSpPr/>
+        <p:nvPr/>
+      </p:nvGrpSpPr>
+      <p:grpSpPr>
+        <a:xfrm>
+          <a:off x="0" y="0"/>
+          <a:ext cx="0" cy="0"/>
+          <a:chOff x="0" y="0"/>
+          <a:chExt cx="0" cy="0"/>
+        </a:xfrm>
+      </p:grpSpPr>
+      <p:sp>
+        <p:nvSpPr>
+          <p:cNvPr id="101" name="R101">
+            <a:extLst>
+              <a:ext uri="{FF2B5EF4-FFF2-40B4-BE49-F238E27FC236}">
+                <a16:creationId xmlns:a16="http://schemas.microsoft.com/office/drawing/2014/main" id="{0895FEE9-5B43-A5C5-C2A0-D0D79F840246}"/>
+              </a:ext>
+            </a:extLst>
+          </p:cNvPr>
+          <p:cNvSpPr/>
+          <p:nvPr/>
+        </p:nvSpPr>
+        <p:spPr>
+          <a:xfrm>
+            <a:off x="1047750" y="800100"/>
+            <a:ext cx="16192500" cy="657225"/>
+          </a:xfrm>
+          <a:prstGeom prst="roundRect">
+            <a:avLst>
+              <a:gd name="adj" fmla="val 8700"/>
+            </a:avLst>
+          </a:prstGeom>
+          <a:solidFill>
+            <a:srgbClr val="E4F3F7"/>
+          </a:solidFill>
+          <a:ln>
+            <a:noFill/>
+          </a:ln>
+        </p:spPr>
+        <p:txBody>
+          <a:bodyPr rtlCol="0" anchor="ctr"/>
+          <a:lstStyle/>
+          <a:p>
+            <a:endParaRPr lang="fr-FR" dirty="0"/>
+          </a:p>
+        </p:txBody>
+      </p:sp>
+      <p:sp>
+        <p:nvSpPr>
+          <p:cNvPr id="102" name="T102">
+            <a:extLst>
+              <a:ext uri="{FF2B5EF4-FFF2-40B4-BE49-F238E27FC236}">
+                <a16:creationId xmlns:a16="http://schemas.microsoft.com/office/drawing/2014/main" id="{2B39CBDC-7924-F8FA-3EEF-D8ADF6630EBD}"/>
+              </a:ext>
+            </a:extLst>
+          </p:cNvPr>
+          <p:cNvSpPr txBox="1"/>
+          <p:nvPr/>
+        </p:nvSpPr>
+        <p:spPr>
+          <a:xfrm>
+            <a:off x="1771650" y="995363"/>
+            <a:ext cx="9500000" cy="304800"/>
+          </a:xfrm>
+          <a:prstGeom prst="rect">
+            <a:avLst/>
+          </a:prstGeom>
+          <a:noFill/>
+        </p:spPr>
+        <p:txBody>
+          <a:bodyPr wrap="square" lIns="27432" tIns="27432" rIns="27432" bIns="27432" anchor="t">
+            <a:noAutofit/>
+          </a:bodyPr>
+          <a:lstStyle/>
+          <a:p>
+            <a:pPr algn="l"/>
+            <a:r>
+              <a:rPr lang="fr-FR" sz="1800" b="1" spc="162" noProof="0" dirty="0">
+                <a:solidFill>
+                  <a:srgbClr val="1A6A77"/>
+                </a:solidFill>
+                <a:latin typeface="Arial"/>
+              </a:rPr>
+              <a:t>Annexe A7 : Qualité logicielle — CI</a:t>
+            </a:r>
+          </a:p>
+        </p:txBody>
+      </p:sp>
+      <p:sp>
+        <p:nvSpPr>
+          <p:cNvPr id="103" name="T103">
+            <a:extLst>
+              <a:ext uri="{FF2B5EF4-FFF2-40B4-BE49-F238E27FC236}">
+                <a16:creationId xmlns:a16="http://schemas.microsoft.com/office/drawing/2014/main" id="{6AAF358F-9A82-E92F-DD0E-398E280AA5C1}"/>
+              </a:ext>
+            </a:extLst>
+          </p:cNvPr>
+          <p:cNvSpPr txBox="1"/>
+          <p:nvPr/>
+        </p:nvSpPr>
+        <p:spPr>
+          <a:xfrm>
+            <a:off x="11500000" y="971550"/>
+            <a:ext cx="5500000" cy="352425"/>
+          </a:xfrm>
+          <a:prstGeom prst="rect">
+            <a:avLst/>
+          </a:prstGeom>
+          <a:noFill/>
+        </p:spPr>
+        <p:txBody>
+          <a:bodyPr wrap="square" lIns="27432" tIns="27432" rIns="27432" bIns="27432" anchor="t">
+            <a:noAutofit/>
+          </a:bodyPr>
+          <a:lstStyle/>
+          <a:p>
+            <a:pPr algn="r"/>
+            <a:r>
+              <a:rPr lang="fr-FR" sz="1800" b="0" noProof="0" dirty="0">
+                <a:solidFill>
+                  <a:srgbClr val="1A6A77"/>
+                </a:solidFill>
+                <a:latin typeface="Arial"/>
+              </a:rPr>
+              <a:t>2 jobs CI verts</a:t>
+            </a:r>
+          </a:p>
+        </p:txBody>
+      </p:sp>
+      <p:sp>
+        <p:nvSpPr>
+          <p:cNvPr id="105" name="T105">
+            <a:extLst>
+              <a:ext uri="{FF2B5EF4-FFF2-40B4-BE49-F238E27FC236}">
+                <a16:creationId xmlns:a16="http://schemas.microsoft.com/office/drawing/2014/main" id="{B694F137-EE5A-683F-2B43-1571E2015D3F}"/>
+              </a:ext>
+            </a:extLst>
+          </p:cNvPr>
+          <p:cNvSpPr txBox="1"/>
+          <p:nvPr/>
+        </p:nvSpPr>
+        <p:spPr>
+          <a:xfrm>
+            <a:off x="9448799" y="1652588"/>
+            <a:ext cx="7874000" cy="304800"/>
+          </a:xfrm>
+          <a:prstGeom prst="rect">
+            <a:avLst/>
+          </a:prstGeom>
+          <a:noFill/>
+        </p:spPr>
+        <p:txBody>
+          <a:bodyPr wrap="square" lIns="27432" tIns="27432" rIns="27432" bIns="27432" anchor="t">
+            <a:noAutofit/>
+          </a:bodyPr>
+          <a:lstStyle/>
+          <a:p>
+            <a:pPr algn="l"/>
+            <a:r>
+              <a:rPr lang="fr-FR" sz="1400" b="1" spc="100" noProof="0" dirty="0">
+                <a:solidFill>
+                  <a:srgbClr val="5A5A5A"/>
+                </a:solidFill>
+                <a:latin typeface="Arial"/>
+              </a:rPr>
+              <a:t>CI — JOB SÉCURITÉ (TRIVY CVE HIGH/CRITIQUE)</a:t>
+            </a:r>
+          </a:p>
+        </p:txBody>
+      </p:sp>
+      <p:sp>
+        <p:nvSpPr>
+          <p:cNvPr id="145" name="T145">
+            <a:extLst>
+              <a:ext uri="{FF2B5EF4-FFF2-40B4-BE49-F238E27FC236}">
+                <a16:creationId xmlns:a16="http://schemas.microsoft.com/office/drawing/2014/main" id="{C610FD6C-8619-E9A1-4780-2B367E2CD81D}"/>
+              </a:ext>
+            </a:extLst>
+          </p:cNvPr>
+          <p:cNvSpPr txBox="1"/>
+          <p:nvPr/>
+        </p:nvSpPr>
+        <p:spPr>
+          <a:xfrm>
+            <a:off x="1130299" y="1652588"/>
+            <a:ext cx="7874000" cy="304800"/>
+          </a:xfrm>
+          <a:prstGeom prst="rect">
+            <a:avLst/>
+          </a:prstGeom>
+          <a:noFill/>
+        </p:spPr>
+        <p:txBody>
+          <a:bodyPr wrap="square" lIns="27432" tIns="27432" rIns="27432" bIns="27432" anchor="t">
+            <a:noAutofit/>
+          </a:bodyPr>
+          <a:lstStyle/>
+          <a:p>
+            <a:pPr algn="l"/>
+            <a:r>
+              <a:rPr lang="fr-FR" sz="1400" b="1" spc="100" noProof="0" dirty="0">
+                <a:solidFill>
+                  <a:srgbClr val="5A5A5A"/>
+                </a:solidFill>
+                <a:latin typeface="Arial"/>
+              </a:rPr>
+              <a:t>CI — JOB QUALITÉ (RUFF, GITLEAKS, TESTS)</a:t>
+            </a:r>
+          </a:p>
+        </p:txBody>
+      </p:sp>
+      <p:sp>
+        <p:nvSpPr>
+          <p:cNvPr id="174" name="T174">
+            <a:extLst>
+              <a:ext uri="{FF2B5EF4-FFF2-40B4-BE49-F238E27FC236}">
+                <a16:creationId xmlns:a16="http://schemas.microsoft.com/office/drawing/2014/main" id="{5C6208E0-BF11-2F27-4687-08A8EA0CDC73}"/>
+              </a:ext>
+            </a:extLst>
+          </p:cNvPr>
+          <p:cNvSpPr txBox="1"/>
+          <p:nvPr/>
+        </p:nvSpPr>
+        <p:spPr>
+          <a:xfrm>
+            <a:off x="1054100" y="9461500"/>
+            <a:ext cx="13970000" cy="355600"/>
+          </a:xfrm>
+          <a:prstGeom prst="rect">
+            <a:avLst/>
+          </a:prstGeom>
+          <a:noFill/>
+        </p:spPr>
+        <p:txBody>
+          <a:bodyPr wrap="square" lIns="27432" tIns="27432" rIns="27432" bIns="27432" anchor="t">
+            <a:noAutofit/>
+          </a:bodyPr>
+          <a:lstStyle/>
+          <a:p>
+            <a:pPr algn="l"/>
+            <a:r>
+              <a:rPr lang="fr-FR" b="0" noProof="0" dirty="0">
+                <a:solidFill>
+                  <a:srgbClr val="6F6F6F"/>
+                </a:solidFill>
+                <a:latin typeface="Arial"/>
+              </a:rPr>
+              <a:t>Annexe A7 · sources :Exécutions GitHub Actions (jobs Qualité et Sécurité)</a:t>
+            </a:r>
+          </a:p>
+        </p:txBody>
+      </p:sp>
+      <p:sp>
+        <p:nvSpPr>
+          <p:cNvPr id="175" name="T175">
+            <a:extLst>
+              <a:ext uri="{FF2B5EF4-FFF2-40B4-BE49-F238E27FC236}">
+                <a16:creationId xmlns:a16="http://schemas.microsoft.com/office/drawing/2014/main" id="{7A533F9B-E612-E8F7-44B0-0771E40E2236}"/>
+              </a:ext>
+            </a:extLst>
+          </p:cNvPr>
+          <p:cNvSpPr txBox="1"/>
+          <p:nvPr/>
+        </p:nvSpPr>
+        <p:spPr>
+          <a:xfrm>
+            <a:off x="17048886" y="9309100"/>
+            <a:ext cx="273913" cy="304800"/>
+          </a:xfrm>
+          <a:prstGeom prst="rect">
+            <a:avLst/>
+          </a:prstGeom>
+          <a:noFill/>
+        </p:spPr>
+        <p:txBody>
+          <a:bodyPr wrap="none" lIns="27432" tIns="27432" rIns="27432" bIns="27432" anchor="ctr" anchorCtr="0">
+            <a:noAutofit/>
+          </a:bodyPr>
+          <a:lstStyle/>
+          <a:p>
+            <a:pPr algn="l"/>
+            <a:r>
+              <a:rPr lang="fr-FR" sz="1400" b="1" noProof="0" dirty="0">
+                <a:solidFill>
+                  <a:srgbClr val="56B9CA"/>
+                </a:solidFill>
+                <a:latin typeface="Arial"/>
+                <a:cs typeface="Arial"/>
+              </a:rPr>
+              <a:t>52</a:t>
+            </a:r>
+          </a:p>
+        </p:txBody>
+      </p:sp>
+      <p:pic>
+        <p:nvPicPr>
+          <p:cNvPr id="14" name="Image 13">
+            <a:extLst>
+              <a:ext uri="{FF2B5EF4-FFF2-40B4-BE49-F238E27FC236}">
+                <a16:creationId xmlns:a16="http://schemas.microsoft.com/office/drawing/2014/main" id="{67295CF2-DDFE-FF0B-6856-882DB370BD78}"/>
+              </a:ext>
+            </a:extLst>
+          </p:cNvPr>
+          <p:cNvPicPr>
+            <a:picLocks noChangeAspect="1"/>
+          </p:cNvPicPr>
+          <p:nvPr/>
+        </p:nvPicPr>
+        <p:blipFill>
+          <a:blip r:embed="rId3"/>
+          <a:stretch>
+            <a:fillRect/>
+          </a:stretch>
+        </p:blipFill>
+        <p:spPr>
+          <a:xfrm>
+            <a:off x="9482630" y="2152651"/>
+            <a:ext cx="7840169" cy="5201376"/>
+          </a:xfrm>
+          <a:prstGeom prst="rect">
+            <a:avLst/>
+          </a:prstGeom>
+        </p:spPr>
+      </p:pic>
+      <p:pic>
+        <p:nvPicPr>
+          <p:cNvPr id="18" name="Image 17">
+            <a:extLst>
+              <a:ext uri="{FF2B5EF4-FFF2-40B4-BE49-F238E27FC236}">
+                <a16:creationId xmlns:a16="http://schemas.microsoft.com/office/drawing/2014/main" id="{6AC18BD6-2145-9D6E-025F-238451CD15B1}"/>
+              </a:ext>
+            </a:extLst>
+          </p:cNvPr>
+          <p:cNvPicPr>
+            <a:picLocks noChangeAspect="1"/>
+          </p:cNvPicPr>
+          <p:nvPr/>
+        </p:nvPicPr>
+        <p:blipFill>
+          <a:blip r:embed="rId4"/>
+          <a:stretch>
+            <a:fillRect/>
+          </a:stretch>
+        </p:blipFill>
+        <p:spPr>
+          <a:xfrm>
+            <a:off x="1130299" y="2152651"/>
+            <a:ext cx="7840169" cy="5201376"/>
+          </a:xfrm>
+          <a:prstGeom prst="rect">
+            <a:avLst/>
+          </a:prstGeom>
+        </p:spPr>
+      </p:pic>
+    </p:spTree>
+    <p:extLst>
+      <p:ext uri="{BB962C8B-B14F-4D97-AF65-F5344CB8AC3E}">
+        <p14:creationId xmlns:p14="http://schemas.microsoft.com/office/powerpoint/2010/main" val="3757691175"/>
+      </p:ext>
+    </p:extLst>
+  </p:cSld>
+  <p:clrMapOvr>
+    <a:masterClrMapping/>
+  </p:clrMapOvr>
+</p:sld>
+</file>
+
 <file path=ppt/slides/slide6.xml><?xml version="1.0" encoding="utf-8"?>
 <p:sld xmlns:a="http://schemas.openxmlformats.org/drawingml/2006/main" xmlns:r="http://schemas.openxmlformats.org/officeDocument/2006/relationships" xmlns:p="http://schemas.openxmlformats.org/presentationml/2006/main">
   <p:cSld>
@@ -65450,7 +66349,7 @@
 
 <file path=ppt/webextensions/taskpanes.xml><?xml version="1.0" encoding="utf-8"?>
 <wetp:taskpanes xmlns:wetp="http://schemas.microsoft.com/office/webextensions/taskpanes/2010/11">
-  <wetp:taskpane dockstate="right" visibility="0" width="458" row="0">
+  <wetp:taskpane dockstate="right" visibility="0" width="350" row="0">
     <wetp:webextensionref xmlns:r="http://schemas.openxmlformats.org/officeDocument/2006/relationships" r:id="rId1"/>
   </wetp:taskpane>
 </wetp:taskpanes>

</xml_diff>

<commit_message>
feat: outillage du livrable et extraction du moteur d'export Excel
- LISEZ-MOI.md + scripts/construire_livrable.py : assemblent dist/ et
  l'archive .zip, avec garde-fous (sorties présentes, ruff sans erreur)
- reporting.excel : moteur d'export §15.4 sorti du notebook et testé ;
  le notebook ne conserve que le jugement (table CONFIGS) et le pilotage
- notebook v1.0 : retrait des # type: ignore, nettoyage des derniers
  renvois « SHAP §12 confirme » du journal, lien registre en §15.2
- pyproject : active la règle de lint PLW2901
</commit_message>
<xml_diff>
--- a/docs/JALB-Decrochage-l1.pptx
+++ b/docs/JALB-Decrochage-l1.pptx
@@ -36362,8 +36362,23 @@
                 </a:solidFill>
                 <a:latin typeface="Arial"/>
               </a:rPr>
-              <a:t>Quelles features retirer de l'artefact déployé au titre de la minimisation ? — Blocs sans apport mesuré (leurres D11, proxies D14) et LMS redondantes sauf une (D20), sur verdict d'ablation §8 ; SHAP §12 confirme.</a:t>
-            </a:r>
+              <a:t>Quelles features retirer de l'artefact déployé au titre de la minimisation ? — Blocs sans apport mesuré (leurres D11, proxies D14) et LMS redondantes sauf une (D20), sur verdict d'ablation </a:t>
+            </a:r>
+            <a:r>
+              <a:rPr lang="fr-FR" sz="1800" b="0" noProof="0">
+                <a:solidFill>
+                  <a:srgbClr val="4A4A4A"/>
+                </a:solidFill>
+                <a:latin typeface="Arial"/>
+              </a:rPr>
+              <a:t>§8.</a:t>
+            </a:r>
+            <a:endParaRPr lang="fr-FR" sz="1800" b="0" noProof="0" dirty="0">
+              <a:solidFill>
+                <a:srgbClr val="4A4A4A"/>
+              </a:solidFill>
+              <a:latin typeface="Arial"/>
+            </a:endParaRPr>
           </a:p>
         </p:txBody>
       </p:sp>

</xml_diff>

<commit_message>
docs: aligne les renvois AUC et précise RGPD/imputation dans le notebook
- résumé et §14.1 : l'AUC 0,945 est mesurée sur le test scellé (§12), les
  familles étant départagées en CV sur le train (§8) ; renvoi §8→§12.1
- art. 22 : rattache le droit à l'explication aux art. 13-14 et 15.1.h
- tableau préprocessing : `etablissement_origine` inconnu imputé par valeur
  fixe (D09), au lieu de « forme sa propre modalité »
- §11 : ajoute le thème `parcours` aux contributions restituées
- régénère le support de soutenance
</commit_message>
<xml_diff>
--- a/docs/JALB-Decrochage-l1.pptx
+++ b/docs/JALB-Decrochage-l1.pptx
@@ -2773,7 +2773,7 @@
             </a:pPr>
             <a:r>
               <a:rPr lang="fr-FR" sz="1200" dirty="0"/>
-              <a:t>Calcul du point de fonctionnement : rappel, précision, F1, F2, volumes</a:t>
+              <a:t>Calcul du point de fonctionnement : rappel, précision, F2, volumes</a:t>
             </a:r>
           </a:p>
           <a:p>
@@ -5309,7 +5309,7 @@
           <a:p>
             <a:fld id="{5BCAD085-E8A6-8845-BD4E-CB4CCA059FC4}" type="datetimeFigureOut">
               <a:rPr lang="en-US" smtClean="0"/>
-              <a:t>8/24/2026</a:t>
+              <a:t>8/25/2026</a:t>
             </a:fld>
             <a:endParaRPr lang="en-US"/>
           </a:p>
@@ -5477,7 +5477,7 @@
           <a:p>
             <a:fld id="{5BCAD085-E8A6-8845-BD4E-CB4CCA059FC4}" type="datetimeFigureOut">
               <a:rPr lang="en-US" smtClean="0"/>
-              <a:t>8/24/2026</a:t>
+              <a:t>8/25/2026</a:t>
             </a:fld>
             <a:endParaRPr lang="en-US"/>
           </a:p>
@@ -5655,7 +5655,7 @@
           <a:p>
             <a:fld id="{5BCAD085-E8A6-8845-BD4E-CB4CCA059FC4}" type="datetimeFigureOut">
               <a:rPr lang="en-US" smtClean="0"/>
-              <a:t>8/24/2026</a:t>
+              <a:t>8/25/2026</a:t>
             </a:fld>
             <a:endParaRPr lang="en-US"/>
           </a:p>
@@ -5823,7 +5823,7 @@
           <a:p>
             <a:fld id="{5BCAD085-E8A6-8845-BD4E-CB4CCA059FC4}" type="datetimeFigureOut">
               <a:rPr lang="en-US" smtClean="0"/>
-              <a:t>8/24/2026</a:t>
+              <a:t>8/25/2026</a:t>
             </a:fld>
             <a:endParaRPr lang="en-US"/>
           </a:p>
@@ -6068,7 +6068,7 @@
           <a:p>
             <a:fld id="{5BCAD085-E8A6-8845-BD4E-CB4CCA059FC4}" type="datetimeFigureOut">
               <a:rPr lang="en-US" smtClean="0"/>
-              <a:t>8/24/2026</a:t>
+              <a:t>8/25/2026</a:t>
             </a:fld>
             <a:endParaRPr lang="en-US"/>
           </a:p>
@@ -6353,7 +6353,7 @@
           <a:p>
             <a:fld id="{5BCAD085-E8A6-8845-BD4E-CB4CCA059FC4}" type="datetimeFigureOut">
               <a:rPr lang="en-US" smtClean="0"/>
-              <a:t>8/24/2026</a:t>
+              <a:t>8/25/2026</a:t>
             </a:fld>
             <a:endParaRPr lang="en-US"/>
           </a:p>
@@ -6772,7 +6772,7 @@
           <a:p>
             <a:fld id="{5BCAD085-E8A6-8845-BD4E-CB4CCA059FC4}" type="datetimeFigureOut">
               <a:rPr lang="en-US" smtClean="0"/>
-              <a:t>8/24/2026</a:t>
+              <a:t>8/25/2026</a:t>
             </a:fld>
             <a:endParaRPr lang="en-US"/>
           </a:p>
@@ -6889,7 +6889,7 @@
           <a:p>
             <a:fld id="{5BCAD085-E8A6-8845-BD4E-CB4CCA059FC4}" type="datetimeFigureOut">
               <a:rPr lang="en-US" smtClean="0"/>
-              <a:t>8/24/2026</a:t>
+              <a:t>8/25/2026</a:t>
             </a:fld>
             <a:endParaRPr lang="en-US"/>
           </a:p>
@@ -6984,7 +6984,7 @@
           <a:p>
             <a:fld id="{5BCAD085-E8A6-8845-BD4E-CB4CCA059FC4}" type="datetimeFigureOut">
               <a:rPr lang="en-US" smtClean="0"/>
-              <a:t>8/24/2026</a:t>
+              <a:t>8/25/2026</a:t>
             </a:fld>
             <a:endParaRPr lang="en-US"/>
           </a:p>
@@ -7259,7 +7259,7 @@
           <a:p>
             <a:fld id="{5BCAD085-E8A6-8845-BD4E-CB4CCA059FC4}" type="datetimeFigureOut">
               <a:rPr lang="en-US" smtClean="0"/>
-              <a:t>8/24/2026</a:t>
+              <a:t>8/25/2026</a:t>
             </a:fld>
             <a:endParaRPr lang="en-US"/>
           </a:p>
@@ -7511,7 +7511,7 @@
           <a:p>
             <a:fld id="{5BCAD085-E8A6-8845-BD4E-CB4CCA059FC4}" type="datetimeFigureOut">
               <a:rPr lang="en-US" smtClean="0"/>
-              <a:t>8/24/2026</a:t>
+              <a:t>8/25/2026</a:t>
             </a:fld>
             <a:endParaRPr lang="en-US"/>
           </a:p>
@@ -7722,7 +7722,7 @@
           <a:p>
             <a:fld id="{5BCAD085-E8A6-8845-BD4E-CB4CCA059FC4}" type="datetimeFigureOut">
               <a:rPr lang="en-US" smtClean="0"/>
-              <a:t>8/24/2026</a:t>
+              <a:t>8/25/2026</a:t>
             </a:fld>
             <a:endParaRPr lang="en-US"/>
           </a:p>
@@ -20006,7 +20006,7 @@
                 </a:solidFill>
                 <a:latin typeface="Arial"/>
               </a:rPr>
-              <a:t>distance_domicile_km, heures_travail_remunere_sem, connexions_lms_30j, moyenne_partiels_s1, motivation, satisfaction, sentiment_appartenance</a:t>
+              <a:t>distance_domicile_km, heures_travail_remunere_sem, connexions_lms_30j, motivation, satisfaction, sentiment_appartenance</a:t>
             </a:r>
           </a:p>
         </p:txBody>
@@ -24717,7 +24717,7 @@
         </p:nvSpPr>
         <p:spPr>
           <a:xfrm>
-            <a:off x="1054100" y="7924800"/>
+            <a:off x="1066800" y="8001000"/>
             <a:ext cx="16179800" cy="965200"/>
           </a:xfrm>
           <a:prstGeom prst="roundRect">
@@ -24749,7 +24749,7 @@
         </p:nvSpPr>
         <p:spPr>
           <a:xfrm>
-            <a:off x="8026400" y="7924800"/>
+            <a:off x="8026400" y="7982856"/>
             <a:ext cx="8953500" cy="965200"/>
           </a:xfrm>
           <a:prstGeom prst="rect">
@@ -24866,7 +24866,7 @@
         </p:nvSpPr>
         <p:spPr>
           <a:xfrm>
-            <a:off x="1308100" y="8191500"/>
+            <a:off x="1308100" y="8235042"/>
             <a:ext cx="2133600" cy="431800"/>
           </a:xfrm>
           <a:prstGeom prst="roundRect">
@@ -24910,7 +24910,7 @@
         </p:nvSpPr>
         <p:spPr>
           <a:xfrm>
-            <a:off x="3594100" y="8191500"/>
+            <a:off x="3594100" y="8235042"/>
             <a:ext cx="2362200" cy="431800"/>
           </a:xfrm>
           <a:prstGeom prst="roundRect">
@@ -24954,7 +24954,7 @@
         </p:nvSpPr>
         <p:spPr>
           <a:xfrm>
-            <a:off x="6108700" y="8191500"/>
+            <a:off x="6108700" y="8235042"/>
             <a:ext cx="1625600" cy="431800"/>
           </a:xfrm>
           <a:prstGeom prst="roundRect">
@@ -29425,7 +29425,7 @@
                 </a:solidFill>
                 <a:latin typeface="Arial"/>
               </a:rPr>
-              <a:t>Livré V1 — ça fait autorité</a:t>
+              <a:t>Livré V1</a:t>
             </a:r>
           </a:p>
         </p:txBody>
@@ -32587,7 +32587,7 @@
                 </a:solidFill>
                 <a:latin typeface="Arial"/>
               </a:rPr>
-              <a:t>Une seule cohorte : rien ne prouve que le modèle tient ailleurs.</a:t>
+              <a:t>Une seule cohorte : rien ne prouve que le modèle généralise correctement sur plusieurs cohortes.</a:t>
             </a:r>
           </a:p>
           <a:p>

</xml_diff>